<commit_message>
Add Significance and Limitations slides to research proposal PPT
</commit_message>
<xml_diff>
--- a/Research_Proposal_Revised.pptx
+++ b/Research_Proposal_Revised.pptx
@@ -19,6 +19,8 @@
     <p:sldId id="267" r:id="rId18"/>
     <p:sldId id="268" r:id="rId19"/>
     <p:sldId id="269" r:id="rId20"/>
+    <p:sldId id="272" r:id="rId23"/>
+    <p:sldId id="273" r:id="rId24"/>
     <p:sldId id="270" r:id="rId21"/>
     <p:sldId id="271" r:id="rId22"/>
   </p:sldIdLst>
@@ -8601,6 +8603,1127 @@
           <a:lstStyle/>
           <a:p>
             <a:pPr algn="ctr"/>
+          </a:p>
+        </p:txBody>
+      </p:sp>
+    </p:spTree>
+  </p:cSld>
+  <p:clrMapOvr>
+    <a:masterClrMapping/>
+  </p:clrMapOvr>
+</p:sld>
+</file>
+
+<file path=ppt/slides/slide17.xml><?xml version="1.0" encoding="utf-8"?>
+<p:sld xmlns:a="http://schemas.openxmlformats.org/drawingml/2006/main" xmlns:p="http://schemas.openxmlformats.org/presentationml/2006/main" xmlns:r="http://schemas.openxmlformats.org/officeDocument/2006/relationships">
+  <p:cSld>
+    <p:bg>
+      <p:bgPr>
+        <a:solidFill>
+          <a:srgbClr val="FFFFFF"/>
+        </a:solidFill>
+        <a:effectLst/>
+      </p:bgPr>
+    </p:bg>
+    <p:spTree>
+      <p:nvGrpSpPr>
+        <p:cNvPr id="1" name=""/>
+        <p:cNvGrpSpPr/>
+        <p:nvPr/>
+      </p:nvGrpSpPr>
+      <p:grpSpPr/>
+      <p:sp>
+        <p:nvSpPr>
+          <p:cNvPr id="2" name="Rectangle 1"/>
+          <p:cNvSpPr/>
+          <p:nvPr/>
+        </p:nvSpPr>
+        <p:spPr>
+          <a:xfrm>
+            <a:off x="0" y="0"/>
+            <a:ext cx="12191695" cy="914400"/>
+          </a:xfrm>
+          <a:prstGeom prst="rect">
+            <a:avLst/>
+          </a:prstGeom>
+          <a:solidFill>
+            <a:srgbClr val="1B3A5C"/>
+          </a:solidFill>
+          <a:ln>
+            <a:noFill/>
+          </a:ln>
+        </p:spPr>
+        <p:style>
+          <a:lnRef idx="1">
+            <a:schemeClr val="accent1"/>
+          </a:lnRef>
+          <a:fillRef idx="3">
+            <a:schemeClr val="accent1"/>
+          </a:fillRef>
+          <a:effectRef idx="2">
+            <a:schemeClr val="accent1"/>
+          </a:effectRef>
+          <a:fontRef idx="minor">
+            <a:schemeClr val="lt1"/>
+          </a:fontRef>
+        </p:style>
+        <p:txBody>
+          <a:bodyPr rtlCol="0" anchor="ctr"/>
+          <a:lstStyle/>
+          <a:p>
+            <a:pPr algn="ctr"/>
+          </a:p>
+        </p:txBody>
+      </p:sp>
+      <p:sp>
+        <p:nvSpPr>
+          <p:cNvPr id="3" name="TextBox 2"/>
+          <p:cNvSpPr txBox="1"/>
+          <p:nvPr/>
+        </p:nvSpPr>
+        <p:spPr>
+          <a:xfrm>
+            <a:off x="457200" y="137160"/>
+            <a:ext cx="10972800" cy="640080"/>
+          </a:xfrm>
+          <a:prstGeom prst="rect">
+            <a:avLst/>
+          </a:prstGeom>
+          <a:noFill/>
+        </p:spPr>
+        <p:txBody>
+          <a:bodyPr wrap="square">
+            <a:spAutoFit/>
+          </a:bodyPr>
+          <a:lstStyle/>
+          <a:p>
+            <a:pPr algn="l">
+              <a:defRPr sz="2400" b="1">
+                <a:solidFill>
+                  <a:srgbClr val="FFFFFF"/>
+                </a:solidFill>
+                <a:latin typeface="Calibri Light"/>
+              </a:defRPr>
+            </a:pPr>
+            <a:r>
+              <a:t>Significance of the Study</a:t>
+            </a:r>
+          </a:p>
+        </p:txBody>
+      </p:sp>
+      <p:sp>
+        <p:nvSpPr>
+          <p:cNvPr id="4" name="Rectangle 3"/>
+          <p:cNvSpPr/>
+          <p:nvPr/>
+        </p:nvSpPr>
+        <p:spPr>
+          <a:xfrm>
+            <a:off x="365760" y="1097280"/>
+            <a:ext cx="5669280" cy="5303520"/>
+          </a:xfrm>
+          <a:prstGeom prst="rect">
+            <a:avLst/>
+          </a:prstGeom>
+          <a:solidFill>
+            <a:srgbClr val="D6EAF8"/>
+          </a:solidFill>
+          <a:ln>
+            <a:noFill/>
+          </a:ln>
+        </p:spPr>
+        <p:style>
+          <a:lnRef idx="1">
+            <a:schemeClr val="accent1"/>
+          </a:lnRef>
+          <a:fillRef idx="3">
+            <a:schemeClr val="accent1"/>
+          </a:fillRef>
+          <a:effectRef idx="2">
+            <a:schemeClr val="accent1"/>
+          </a:effectRef>
+          <a:fontRef idx="minor">
+            <a:schemeClr val="lt1"/>
+          </a:fontRef>
+        </p:style>
+        <p:txBody>
+          <a:bodyPr rtlCol="0" anchor="ctr"/>
+          <a:lstStyle/>
+          <a:p>
+            <a:pPr algn="ctr"/>
+          </a:p>
+        </p:txBody>
+      </p:sp>
+      <p:sp>
+        <p:nvSpPr>
+          <p:cNvPr id="5" name="TextBox 4"/>
+          <p:cNvSpPr txBox="1"/>
+          <p:nvPr/>
+        </p:nvSpPr>
+        <p:spPr>
+          <a:xfrm>
+            <a:off x="548640" y="1188720"/>
+            <a:ext cx="5303520" cy="365760"/>
+          </a:xfrm>
+          <a:prstGeom prst="rect">
+            <a:avLst/>
+          </a:prstGeom>
+          <a:noFill/>
+        </p:spPr>
+        <p:txBody>
+          <a:bodyPr wrap="square">
+            <a:spAutoFit/>
+          </a:bodyPr>
+          <a:lstStyle/>
+          <a:p>
+            <a:pPr algn="l">
+              <a:defRPr sz="1200" b="1">
+                <a:solidFill>
+                  <a:srgbClr val="1B3A5C"/>
+                </a:solidFill>
+                <a:latin typeface="Calibri"/>
+              </a:defRPr>
+            </a:pPr>
+            <a:r>
+              <a:t>CLINICAL SIGNIFICANCE</a:t>
+            </a:r>
+          </a:p>
+        </p:txBody>
+      </p:sp>
+      <p:sp>
+        <p:nvSpPr>
+          <p:cNvPr id="6" name="TextBox 5"/>
+          <p:cNvSpPr txBox="1"/>
+          <p:nvPr/>
+        </p:nvSpPr>
+        <p:spPr>
+          <a:xfrm>
+            <a:off x="548640" y="1554480"/>
+            <a:ext cx="5303520" cy="4663440"/>
+          </a:xfrm>
+          <a:prstGeom prst="rect">
+            <a:avLst/>
+          </a:prstGeom>
+          <a:noFill/>
+        </p:spPr>
+        <p:txBody>
+          <a:bodyPr wrap="square">
+            <a:spAutoFit/>
+          </a:bodyPr>
+          <a:lstStyle/>
+          <a:p>
+            <a:pPr>
+              <a:defRPr sz="1100">
+                <a:solidFill>
+                  <a:srgbClr val="2C3E50"/>
+                </a:solidFill>
+                <a:latin typeface="Calibri"/>
+              </a:defRPr>
+            </a:pPr>
+            <a:r>
+              <a:t>First intervention study targeting alexithymia in opioid-dependent individuals stratified by HIV status</a:t>
+            </a:r>
+          </a:p>
+          <a:p>
+            <a:pPr>
+              <a:spcAft>
+                <a:spcPts val="500"/>
+              </a:spcAft>
+              <a:defRPr sz="1100" b="0">
+                <a:solidFill>
+                  <a:srgbClr val="2C3E50"/>
+                </a:solidFill>
+                <a:latin typeface="Calibri"/>
+              </a:defRPr>
+            </a:pPr>
+            <a:r>
+              <a:t>If effective, EFST can be integrated into standard 1-month de-addiction programmes at low cost</a:t>
+            </a:r>
+          </a:p>
+          <a:p>
+            <a:pPr>
+              <a:spcAft>
+                <a:spcPts val="500"/>
+              </a:spcAft>
+              <a:defRPr sz="1100" b="0">
+                <a:solidFill>
+                  <a:srgbClr val="2C3E50"/>
+                </a:solidFill>
+                <a:latin typeface="Calibri"/>
+              </a:defRPr>
+            </a:pPr>
+            <a:r>
+              <a:t>Informs treatment personalisation — HIV+ individuals may require adapted interventions</a:t>
+            </a:r>
+          </a:p>
+          <a:p>
+            <a:pPr>
+              <a:spcAft>
+                <a:spcPts val="500"/>
+              </a:spcAft>
+              <a:defRPr sz="1100" b="0">
+                <a:solidFill>
+                  <a:srgbClr val="2C3E50"/>
+                </a:solidFill>
+                <a:latin typeface="Calibri"/>
+              </a:defRPr>
+            </a:pPr>
+            <a:r>
+              <a:t>Reducing alexithymia may improve emotional coping and reduce relapse risk post-discharge</a:t>
+            </a:r>
+          </a:p>
+          <a:p>
+            <a:pPr>
+              <a:spcAft>
+                <a:spcPts val="500"/>
+              </a:spcAft>
+              <a:defRPr sz="1100" b="0">
+                <a:solidFill>
+                  <a:srgbClr val="2C3E50"/>
+                </a:solidFill>
+                <a:latin typeface="Calibri"/>
+              </a:defRPr>
+            </a:pPr>
+            <a:r>
+              <a:t>Addresses a dual-burden population (opioid dependence + HIV) with compounded vulnerabilities</a:t>
+            </a:r>
+          </a:p>
+          <a:p>
+            <a:pPr>
+              <a:spcAft>
+                <a:spcPts val="500"/>
+              </a:spcAft>
+              <a:defRPr sz="1100" b="0">
+                <a:solidFill>
+                  <a:srgbClr val="2C3E50"/>
+                </a:solidFill>
+                <a:latin typeface="Calibri"/>
+              </a:defRPr>
+            </a:pPr>
+            <a:r>
+              <a:t>Provides feasibility data for EFST delivery within standard inpatient rehabilitation timeframe</a:t>
+            </a:r>
+          </a:p>
+        </p:txBody>
+      </p:sp>
+      <p:sp>
+        <p:nvSpPr>
+          <p:cNvPr id="7" name="Rectangle 6"/>
+          <p:cNvSpPr/>
+          <p:nvPr/>
+        </p:nvSpPr>
+        <p:spPr>
+          <a:xfrm>
+            <a:off x="6217920" y="1097280"/>
+            <a:ext cx="5669280" cy="5303520"/>
+          </a:xfrm>
+          <a:prstGeom prst="rect">
+            <a:avLst/>
+          </a:prstGeom>
+          <a:solidFill>
+            <a:srgbClr val="D5F5E3"/>
+          </a:solidFill>
+          <a:ln>
+            <a:noFill/>
+          </a:ln>
+        </p:spPr>
+        <p:style>
+          <a:lnRef idx="1">
+            <a:schemeClr val="accent1"/>
+          </a:lnRef>
+          <a:fillRef idx="3">
+            <a:schemeClr val="accent1"/>
+          </a:fillRef>
+          <a:effectRef idx="2">
+            <a:schemeClr val="accent1"/>
+          </a:effectRef>
+          <a:fontRef idx="minor">
+            <a:schemeClr val="lt1"/>
+          </a:fontRef>
+        </p:style>
+        <p:txBody>
+          <a:bodyPr rtlCol="0" anchor="ctr"/>
+          <a:lstStyle/>
+          <a:p>
+            <a:pPr algn="ctr"/>
+          </a:p>
+        </p:txBody>
+      </p:sp>
+      <p:sp>
+        <p:nvSpPr>
+          <p:cNvPr id="8" name="TextBox 7"/>
+          <p:cNvSpPr txBox="1"/>
+          <p:nvPr/>
+        </p:nvSpPr>
+        <p:spPr>
+          <a:xfrm>
+            <a:off x="6400800" y="1188720"/>
+            <a:ext cx="5303520" cy="365760"/>
+          </a:xfrm>
+          <a:prstGeom prst="rect">
+            <a:avLst/>
+          </a:prstGeom>
+          <a:noFill/>
+        </p:spPr>
+        <p:txBody>
+          <a:bodyPr wrap="square">
+            <a:spAutoFit/>
+          </a:bodyPr>
+          <a:lstStyle/>
+          <a:p>
+            <a:pPr algn="l">
+              <a:defRPr sz="1200" b="1">
+                <a:solidFill>
+                  <a:srgbClr val="1E8A49"/>
+                </a:solidFill>
+                <a:latin typeface="Calibri"/>
+              </a:defRPr>
+            </a:pPr>
+            <a:r>
+              <a:t>RESEARCH SIGNIFICANCE</a:t>
+            </a:r>
+          </a:p>
+        </p:txBody>
+      </p:sp>
+      <p:sp>
+        <p:nvSpPr>
+          <p:cNvPr id="9" name="TextBox 8"/>
+          <p:cNvSpPr txBox="1"/>
+          <p:nvPr/>
+        </p:nvSpPr>
+        <p:spPr>
+          <a:xfrm>
+            <a:off x="6400800" y="1554480"/>
+            <a:ext cx="5303520" cy="4663440"/>
+          </a:xfrm>
+          <a:prstGeom prst="rect">
+            <a:avLst/>
+          </a:prstGeom>
+          <a:noFill/>
+        </p:spPr>
+        <p:txBody>
+          <a:bodyPr wrap="square">
+            <a:spAutoFit/>
+          </a:bodyPr>
+          <a:lstStyle/>
+          <a:p>
+            <a:pPr>
+              <a:defRPr sz="1100">
+                <a:solidFill>
+                  <a:srgbClr val="2C3E50"/>
+                </a:solidFill>
+                <a:latin typeface="Calibri"/>
+              </a:defRPr>
+            </a:pPr>
+            <a:r>
+              <a:t>Fills a critical gap — no prior study evaluates EFST in opioid-dependent adults</a:t>
+            </a:r>
+          </a:p>
+          <a:p>
+            <a:pPr>
+              <a:spcAft>
+                <a:spcPts val="500"/>
+              </a:spcAft>
+              <a:defRPr sz="1100" b="0">
+                <a:solidFill>
+                  <a:srgbClr val="2C3E50"/>
+                </a:solidFill>
+                <a:latin typeface="Calibri"/>
+              </a:defRPr>
+            </a:pPr>
+            <a:r>
+              <a:t>First Indian study examining alexithymia as an intervention target in de-addiction settings</a:t>
+            </a:r>
+          </a:p>
+          <a:p>
+            <a:pPr>
+              <a:spcAft>
+                <a:spcPts val="500"/>
+              </a:spcAft>
+              <a:defRPr sz="1100" b="0">
+                <a:solidFill>
+                  <a:srgbClr val="2C3E50"/>
+                </a:solidFill>
+                <a:latin typeface="Calibri"/>
+              </a:defRPr>
+            </a:pPr>
+            <a:r>
+              <a:t>Tests whether alexithymia (often considered stable) is modifiable through brief structured intervention</a:t>
+            </a:r>
+          </a:p>
+          <a:p>
+            <a:pPr>
+              <a:spcAft>
+                <a:spcPts val="500"/>
+              </a:spcAft>
+              <a:defRPr sz="1100" b="0">
+                <a:solidFill>
+                  <a:srgbClr val="2C3E50"/>
+                </a:solidFill>
+                <a:latin typeface="Calibri"/>
+              </a:defRPr>
+            </a:pPr>
+            <a:r>
+              <a:t>Examines whether HIV-related neurobiological changes affect capacity to benefit from EFST</a:t>
+            </a:r>
+          </a:p>
+          <a:p>
+            <a:pPr>
+              <a:spcAft>
+                <a:spcPts val="500"/>
+              </a:spcAft>
+              <a:defRPr sz="1100" b="0">
+                <a:solidFill>
+                  <a:srgbClr val="2C3E50"/>
+                </a:solidFill>
+                <a:latin typeface="Calibri"/>
+              </a:defRPr>
+            </a:pPr>
+            <a:r>
+              <a:t>Contributes to the evidence base on emotion-focused approaches in addiction populations</a:t>
+            </a:r>
+          </a:p>
+          <a:p>
+            <a:pPr>
+              <a:spcAft>
+                <a:spcPts val="500"/>
+              </a:spcAft>
+              <a:defRPr sz="1100" b="0">
+                <a:solidFill>
+                  <a:srgbClr val="2C3E50"/>
+                </a:solidFill>
+                <a:latin typeface="Calibri"/>
+              </a:defRPr>
+            </a:pPr>
+            <a:r>
+              <a:t>Scalable — can be implemented in government de-addiction programmes across India if effective</a:t>
+            </a:r>
+          </a:p>
+        </p:txBody>
+      </p:sp>
+    </p:spTree>
+  </p:cSld>
+  <p:clrMapOvr>
+    <a:masterClrMapping/>
+  </p:clrMapOvr>
+</p:sld>
+</file>
+
+<file path=ppt/slides/slide18.xml><?xml version="1.0" encoding="utf-8"?>
+<p:sld xmlns:a="http://schemas.openxmlformats.org/drawingml/2006/main" xmlns:p="http://schemas.openxmlformats.org/presentationml/2006/main" xmlns:r="http://schemas.openxmlformats.org/officeDocument/2006/relationships">
+  <p:cSld>
+    <p:bg>
+      <p:bgPr>
+        <a:solidFill>
+          <a:srgbClr val="FFFFFF"/>
+        </a:solidFill>
+        <a:effectLst/>
+      </p:bgPr>
+    </p:bg>
+    <p:spTree>
+      <p:nvGrpSpPr>
+        <p:cNvPr id="1" name=""/>
+        <p:cNvGrpSpPr/>
+        <p:nvPr/>
+      </p:nvGrpSpPr>
+      <p:grpSpPr/>
+      <p:sp>
+        <p:nvSpPr>
+          <p:cNvPr id="2" name="Rectangle 1"/>
+          <p:cNvSpPr/>
+          <p:nvPr/>
+        </p:nvSpPr>
+        <p:spPr>
+          <a:xfrm>
+            <a:off x="0" y="0"/>
+            <a:ext cx="12191695" cy="914400"/>
+          </a:xfrm>
+          <a:prstGeom prst="rect">
+            <a:avLst/>
+          </a:prstGeom>
+          <a:solidFill>
+            <a:srgbClr val="1B3A5C"/>
+          </a:solidFill>
+          <a:ln>
+            <a:noFill/>
+          </a:ln>
+        </p:spPr>
+        <p:style>
+          <a:lnRef idx="1">
+            <a:schemeClr val="accent1"/>
+          </a:lnRef>
+          <a:fillRef idx="3">
+            <a:schemeClr val="accent1"/>
+          </a:fillRef>
+          <a:effectRef idx="2">
+            <a:schemeClr val="accent1"/>
+          </a:effectRef>
+          <a:fontRef idx="minor">
+            <a:schemeClr val="lt1"/>
+          </a:fontRef>
+        </p:style>
+        <p:txBody>
+          <a:bodyPr rtlCol="0" anchor="ctr"/>
+          <a:lstStyle/>
+          <a:p>
+            <a:pPr algn="ctr"/>
+          </a:p>
+        </p:txBody>
+      </p:sp>
+      <p:sp>
+        <p:nvSpPr>
+          <p:cNvPr id="3" name="TextBox 2"/>
+          <p:cNvSpPr txBox="1"/>
+          <p:nvPr/>
+        </p:nvSpPr>
+        <p:spPr>
+          <a:xfrm>
+            <a:off x="457200" y="137160"/>
+            <a:ext cx="10972800" cy="640080"/>
+          </a:xfrm>
+          <a:prstGeom prst="rect">
+            <a:avLst/>
+          </a:prstGeom>
+          <a:noFill/>
+        </p:spPr>
+        <p:txBody>
+          <a:bodyPr wrap="square">
+            <a:spAutoFit/>
+          </a:bodyPr>
+          <a:lstStyle/>
+          <a:p>
+            <a:pPr algn="l">
+              <a:defRPr sz="2400" b="1">
+                <a:solidFill>
+                  <a:srgbClr val="FFFFFF"/>
+                </a:solidFill>
+                <a:latin typeface="Calibri Light"/>
+              </a:defRPr>
+            </a:pPr>
+            <a:r>
+              <a:t>Limitations of the Study</a:t>
+            </a:r>
+          </a:p>
+        </p:txBody>
+      </p:sp>
+      <p:sp>
+        <p:nvSpPr>
+          <p:cNvPr id="4" name="Rectangle 3"/>
+          <p:cNvSpPr/>
+          <p:nvPr/>
+        </p:nvSpPr>
+        <p:spPr>
+          <a:xfrm>
+            <a:off x="365760" y="1097280"/>
+            <a:ext cx="3657600" cy="5486400"/>
+          </a:xfrm>
+          <a:prstGeom prst="rect">
+            <a:avLst/>
+          </a:prstGeom>
+          <a:solidFill>
+            <a:srgbClr val="FADBD8"/>
+          </a:solidFill>
+          <a:ln>
+            <a:noFill/>
+          </a:ln>
+        </p:spPr>
+        <p:style>
+          <a:lnRef idx="1">
+            <a:schemeClr val="accent1"/>
+          </a:lnRef>
+          <a:fillRef idx="3">
+            <a:schemeClr val="accent1"/>
+          </a:fillRef>
+          <a:effectRef idx="2">
+            <a:schemeClr val="accent1"/>
+          </a:effectRef>
+          <a:fontRef idx="minor">
+            <a:schemeClr val="lt1"/>
+          </a:fontRef>
+        </p:style>
+        <p:txBody>
+          <a:bodyPr rtlCol="0" anchor="ctr"/>
+          <a:lstStyle/>
+          <a:p>
+            <a:pPr algn="ctr"/>
+          </a:p>
+        </p:txBody>
+      </p:sp>
+      <p:sp>
+        <p:nvSpPr>
+          <p:cNvPr id="5" name="TextBox 4"/>
+          <p:cNvSpPr txBox="1"/>
+          <p:nvPr/>
+        </p:nvSpPr>
+        <p:spPr>
+          <a:xfrm>
+            <a:off x="548640" y="1188720"/>
+            <a:ext cx="3291840" cy="365760"/>
+          </a:xfrm>
+          <a:prstGeom prst="rect">
+            <a:avLst/>
+          </a:prstGeom>
+          <a:noFill/>
+        </p:spPr>
+        <p:txBody>
+          <a:bodyPr wrap="square">
+            <a:spAutoFit/>
+          </a:bodyPr>
+          <a:lstStyle/>
+          <a:p>
+            <a:pPr algn="l">
+              <a:defRPr sz="1100" b="1">
+                <a:solidFill>
+                  <a:srgbClr val="C0392B"/>
+                </a:solidFill>
+                <a:latin typeface="Calibri"/>
+              </a:defRPr>
+            </a:pPr>
+            <a:r>
+              <a:t>DESIGN</a:t>
+            </a:r>
+          </a:p>
+        </p:txBody>
+      </p:sp>
+      <p:sp>
+        <p:nvSpPr>
+          <p:cNvPr id="6" name="TextBox 5"/>
+          <p:cNvSpPr txBox="1"/>
+          <p:nvPr/>
+        </p:nvSpPr>
+        <p:spPr>
+          <a:xfrm>
+            <a:off x="548640" y="1554480"/>
+            <a:ext cx="3291840" cy="4846320"/>
+          </a:xfrm>
+          <a:prstGeom prst="rect">
+            <a:avLst/>
+          </a:prstGeom>
+          <a:noFill/>
+        </p:spPr>
+        <p:txBody>
+          <a:bodyPr wrap="square">
+            <a:spAutoFit/>
+          </a:bodyPr>
+          <a:lstStyle/>
+          <a:p>
+            <a:pPr>
+              <a:defRPr sz="1000">
+                <a:solidFill>
+                  <a:srgbClr val="2C3E50"/>
+                </a:solidFill>
+                <a:latin typeface="Calibri"/>
+              </a:defRPr>
+            </a:pPr>
+            <a:r>
+              <a:t>No untreated control group — improvements may reflect natural recovery or concurrent treatment</a:t>
+            </a:r>
+          </a:p>
+          <a:p>
+            <a:pPr>
+              <a:spcAft>
+                <a:spcPts val="500"/>
+              </a:spcAft>
+              <a:defRPr sz="1000" b="0">
+                <a:solidFill>
+                  <a:srgbClr val="2C3E50"/>
+                </a:solidFill>
+                <a:latin typeface="Calibri"/>
+              </a:defRPr>
+            </a:pPr>
+            <a:r>
+              <a:t>Quasi-experimental — groups based on pre-existing HIV status, not randomised</a:t>
+            </a:r>
+          </a:p>
+          <a:p>
+            <a:pPr>
+              <a:spcAft>
+                <a:spcPts val="500"/>
+              </a:spcAft>
+              <a:defRPr sz="1000" b="0">
+                <a:solidFill>
+                  <a:srgbClr val="2C3E50"/>
+                </a:solidFill>
+                <a:latin typeface="Calibri"/>
+              </a:defRPr>
+            </a:pPr>
+            <a:r>
+              <a:t>No blinding of participants or researcher</a:t>
+            </a:r>
+          </a:p>
+          <a:p>
+            <a:pPr>
+              <a:spcAft>
+                <a:spcPts val="500"/>
+              </a:spcAft>
+              <a:defRPr sz="1000" b="0">
+                <a:solidFill>
+                  <a:srgbClr val="2C3E50"/>
+                </a:solidFill>
+                <a:latin typeface="Calibri"/>
+              </a:defRPr>
+            </a:pPr>
+            <a:r>
+              <a:t>No long-term follow-up — durability of gains post-discharge unknown</a:t>
+            </a:r>
+          </a:p>
+          <a:p>
+            <a:pPr>
+              <a:spcAft>
+                <a:spcPts val="500"/>
+              </a:spcAft>
+              <a:defRPr sz="1000" b="0">
+                <a:solidFill>
+                  <a:srgbClr val="2C3E50"/>
+                </a:solidFill>
+                <a:latin typeface="Calibri"/>
+              </a:defRPr>
+            </a:pPr>
+            <a:r>
+              <a:t>Brief duration (8 sessions/4 weeks) may be insufficient for stable trait change</a:t>
+            </a:r>
+          </a:p>
+        </p:txBody>
+      </p:sp>
+      <p:sp>
+        <p:nvSpPr>
+          <p:cNvPr id="7" name="Rectangle 6"/>
+          <p:cNvSpPr/>
+          <p:nvPr/>
+        </p:nvSpPr>
+        <p:spPr>
+          <a:xfrm>
+            <a:off x="4206240" y="1097280"/>
+            <a:ext cx="3657600" cy="5486400"/>
+          </a:xfrm>
+          <a:prstGeom prst="rect">
+            <a:avLst/>
+          </a:prstGeom>
+          <a:solidFill>
+            <a:srgbClr val="FDF2E9"/>
+          </a:solidFill>
+          <a:ln>
+            <a:noFill/>
+          </a:ln>
+        </p:spPr>
+        <p:style>
+          <a:lnRef idx="1">
+            <a:schemeClr val="accent1"/>
+          </a:lnRef>
+          <a:fillRef idx="3">
+            <a:schemeClr val="accent1"/>
+          </a:fillRef>
+          <a:effectRef idx="2">
+            <a:schemeClr val="accent1"/>
+          </a:effectRef>
+          <a:fontRef idx="minor">
+            <a:schemeClr val="lt1"/>
+          </a:fontRef>
+        </p:style>
+        <p:txBody>
+          <a:bodyPr rtlCol="0" anchor="ctr"/>
+          <a:lstStyle/>
+          <a:p>
+            <a:pPr algn="ctr"/>
+          </a:p>
+        </p:txBody>
+      </p:sp>
+      <p:sp>
+        <p:nvSpPr>
+          <p:cNvPr id="8" name="TextBox 7"/>
+          <p:cNvSpPr txBox="1"/>
+          <p:nvPr/>
+        </p:nvSpPr>
+        <p:spPr>
+          <a:xfrm>
+            <a:off x="4389120" y="1188720"/>
+            <a:ext cx="3291840" cy="365760"/>
+          </a:xfrm>
+          <a:prstGeom prst="rect">
+            <a:avLst/>
+          </a:prstGeom>
+          <a:noFill/>
+        </p:spPr>
+        <p:txBody>
+          <a:bodyPr wrap="square">
+            <a:spAutoFit/>
+          </a:bodyPr>
+          <a:lstStyle/>
+          <a:p>
+            <a:pPr algn="l">
+              <a:defRPr sz="1100" b="1">
+                <a:solidFill>
+                  <a:srgbClr val="D35A00"/>
+                </a:solidFill>
+                <a:latin typeface="Calibri"/>
+              </a:defRPr>
+            </a:pPr>
+            <a:r>
+              <a:t>SAMPLE</a:t>
+            </a:r>
+          </a:p>
+        </p:txBody>
+      </p:sp>
+      <p:sp>
+        <p:nvSpPr>
+          <p:cNvPr id="9" name="TextBox 8"/>
+          <p:cNvSpPr txBox="1"/>
+          <p:nvPr/>
+        </p:nvSpPr>
+        <p:spPr>
+          <a:xfrm>
+            <a:off x="4389120" y="1554480"/>
+            <a:ext cx="3291840" cy="4846320"/>
+          </a:xfrm>
+          <a:prstGeom prst="rect">
+            <a:avLst/>
+          </a:prstGeom>
+          <a:noFill/>
+        </p:spPr>
+        <p:txBody>
+          <a:bodyPr wrap="square">
+            <a:spAutoFit/>
+          </a:bodyPr>
+          <a:lstStyle/>
+          <a:p>
+            <a:pPr>
+              <a:defRPr sz="1000">
+                <a:solidFill>
+                  <a:srgbClr val="2C3E50"/>
+                </a:solidFill>
+                <a:latin typeface="Calibri"/>
+              </a:defRPr>
+            </a:pPr>
+            <a:r>
+              <a:t>Male-only sample — limits generalisability to female populations</a:t>
+            </a:r>
+          </a:p>
+          <a:p>
+            <a:pPr>
+              <a:spcAft>
+                <a:spcPts val="500"/>
+              </a:spcAft>
+              <a:defRPr sz="1000" b="0">
+                <a:solidFill>
+                  <a:srgbClr val="2C3E50"/>
+                </a:solidFill>
+                <a:latin typeface="Calibri"/>
+              </a:defRPr>
+            </a:pPr>
+            <a:r>
+              <a:t>Single-site data — may not generalise to other settings/regions</a:t>
+            </a:r>
+          </a:p>
+          <a:p>
+            <a:pPr>
+              <a:spcAft>
+                <a:spcPts val="500"/>
+              </a:spcAft>
+              <a:defRPr sz="1000" b="0">
+                <a:solidFill>
+                  <a:srgbClr val="2C3E50"/>
+                </a:solidFill>
+                <a:latin typeface="Calibri"/>
+              </a:defRPr>
+            </a:pPr>
+            <a:r>
+              <a:t>Purposive sampling — limits external validity</a:t>
+            </a:r>
+          </a:p>
+          <a:p>
+            <a:pPr>
+              <a:spcAft>
+                <a:spcPts val="500"/>
+              </a:spcAft>
+              <a:defRPr sz="1000" b="0">
+                <a:solidFill>
+                  <a:srgbClr val="2C3E50"/>
+                </a:solidFill>
+                <a:latin typeface="Calibri"/>
+              </a:defRPr>
+            </a:pPr>
+            <a:r>
+              <a:t>N = 60 may be underpowered for small-to-medium or interaction effects</a:t>
+            </a:r>
+          </a:p>
+        </p:txBody>
+      </p:sp>
+      <p:sp>
+        <p:nvSpPr>
+          <p:cNvPr id="10" name="Rectangle 9"/>
+          <p:cNvSpPr/>
+          <p:nvPr/>
+        </p:nvSpPr>
+        <p:spPr>
+          <a:xfrm>
+            <a:off x="8046720" y="1097280"/>
+            <a:ext cx="3840480" cy="5486400"/>
+          </a:xfrm>
+          <a:prstGeom prst="rect">
+            <a:avLst/>
+          </a:prstGeom>
+          <a:solidFill>
+            <a:srgbClr val="E8DAEF"/>
+          </a:solidFill>
+          <a:ln>
+            <a:noFill/>
+          </a:ln>
+        </p:spPr>
+        <p:style>
+          <a:lnRef idx="1">
+            <a:schemeClr val="accent1"/>
+          </a:lnRef>
+          <a:fillRef idx="3">
+            <a:schemeClr val="accent1"/>
+          </a:fillRef>
+          <a:effectRef idx="2">
+            <a:schemeClr val="accent1"/>
+          </a:effectRef>
+          <a:fontRef idx="minor">
+            <a:schemeClr val="lt1"/>
+          </a:fontRef>
+        </p:style>
+        <p:txBody>
+          <a:bodyPr rtlCol="0" anchor="ctr"/>
+          <a:lstStyle/>
+          <a:p>
+            <a:pPr algn="ctr"/>
+          </a:p>
+        </p:txBody>
+      </p:sp>
+      <p:sp>
+        <p:nvSpPr>
+          <p:cNvPr id="11" name="TextBox 10"/>
+          <p:cNvSpPr txBox="1"/>
+          <p:nvPr/>
+        </p:nvSpPr>
+        <p:spPr>
+          <a:xfrm>
+            <a:off x="8229600" y="1188720"/>
+            <a:ext cx="3474720" cy="365760"/>
+          </a:xfrm>
+          <a:prstGeom prst="rect">
+            <a:avLst/>
+          </a:prstGeom>
+          <a:noFill/>
+        </p:spPr>
+        <p:txBody>
+          <a:bodyPr wrap="square">
+            <a:spAutoFit/>
+          </a:bodyPr>
+          <a:lstStyle/>
+          <a:p>
+            <a:pPr algn="l">
+              <a:defRPr sz="1000" b="1">
+                <a:solidFill>
+                  <a:srgbClr val="6C3A83"/>
+                </a:solidFill>
+                <a:latin typeface="Calibri"/>
+              </a:defRPr>
+            </a:pPr>
+            <a:r>
+              <a:t>MEASUREMENT &amp; CONFOUNDS</a:t>
+            </a:r>
+          </a:p>
+        </p:txBody>
+      </p:sp>
+      <p:sp>
+        <p:nvSpPr>
+          <p:cNvPr id="12" name="TextBox 11"/>
+          <p:cNvSpPr txBox="1"/>
+          <p:nvPr/>
+        </p:nvSpPr>
+        <p:spPr>
+          <a:xfrm>
+            <a:off x="8229600" y="1554480"/>
+            <a:ext cx="3474720" cy="4846320"/>
+          </a:xfrm>
+          <a:prstGeom prst="rect">
+            <a:avLst/>
+          </a:prstGeom>
+          <a:noFill/>
+        </p:spPr>
+        <p:txBody>
+          <a:bodyPr wrap="square">
+            <a:spAutoFit/>
+          </a:bodyPr>
+          <a:lstStyle/>
+          <a:p>
+            <a:pPr>
+              <a:defRPr sz="1000">
+                <a:solidFill>
+                  <a:srgbClr val="2C3E50"/>
+                </a:solidFill>
+                <a:latin typeface="Calibri"/>
+              </a:defRPr>
+            </a:pPr>
+            <a:r>
+              <a:t>Self-report paradox — alexithymic individuals may underreport deficits on TAS-20</a:t>
+            </a:r>
+          </a:p>
+          <a:p>
+            <a:pPr>
+              <a:spcAft>
+                <a:spcPts val="500"/>
+              </a:spcAft>
+              <a:defRPr sz="1000" b="0">
+                <a:solidFill>
+                  <a:srgbClr val="2C3E50"/>
+                </a:solidFill>
+                <a:latin typeface="Calibri"/>
+              </a:defRPr>
+            </a:pPr>
+            <a:r>
+              <a:t>No performance-based emotion recognition measure included</a:t>
+            </a:r>
+          </a:p>
+          <a:p>
+            <a:pPr>
+              <a:spcAft>
+                <a:spcPts val="500"/>
+              </a:spcAft>
+              <a:defRPr sz="1000" b="0">
+                <a:solidFill>
+                  <a:srgbClr val="2C3E50"/>
+                </a:solidFill>
+                <a:latin typeface="Calibri"/>
+              </a:defRPr>
+            </a:pPr>
+            <a:r>
+              <a:t>Concurrent de-addiction treatment may confound EFST effects</a:t>
+            </a:r>
+          </a:p>
+          <a:p>
+            <a:pPr>
+              <a:spcAft>
+                <a:spcPts val="500"/>
+              </a:spcAft>
+              <a:defRPr sz="1000" b="0">
+                <a:solidFill>
+                  <a:srgbClr val="2C3E50"/>
+                </a:solidFill>
+                <a:latin typeface="Calibri"/>
+              </a:defRPr>
+            </a:pPr>
+            <a:r>
+              <a:t>ART side effects may independently affect emotional processing</a:t>
+            </a:r>
+          </a:p>
+          <a:p>
+            <a:pPr>
+              <a:spcAft>
+                <a:spcPts val="500"/>
+              </a:spcAft>
+              <a:defRPr sz="1000" b="0">
+                <a:solidFill>
+                  <a:srgbClr val="2C3E50"/>
+                </a:solidFill>
+                <a:latin typeface="Calibri"/>
+              </a:defRPr>
+            </a:pPr>
+            <a:r>
+              <a:t>Single therapist — therapist effects cannot be separated from intervention effects</a:t>
+            </a:r>
           </a:p>
         </p:txBody>
       </p:sp>

</xml_diff>